<commit_message>
deck_zwfs: the Zernike sensor deck (DRAFT, 9 slides) + builder divider fix
New deck for the ZWFS campaign: the idea (self-referenced common-path
interferometer), the setup (TG96 test arm alone -- only the sensor
changes), the mask at VSG2 hardware numbers (346.2 nm etch, 9-spot
table), S1 first light (8 nm ripple from one frame at gain 0.93;
no-dimple control -0.07; defocus property 0.32), the side-by-side
table vs the Twyman-Green PSI, and the actuator-space head-to-head
plan.  Figures from zwfs_s1_figs.m (mmacos zwfs_dm96).

make_brief_slides.py: mid-file '# ' lines now render as plain divider
slides (DECK_STYLE) -- previously they leaked verbatim as body text
onto the preceding slide (deck_tg_fang carried a stray '# Backup'
paragraph; its pptx is rebuilt here, 17 -> 18 slides, md unchanged).
Keysight decks have no mid-file '# ' lines -- unaffected.

Co-Authored-By: Claude Fable 5 <noreply@anthropic.com>
</commit_message>
<xml_diff>
--- a/demo_session/deck_tg_fang.pptx
+++ b/demo_session/deck_tg_fang.pptx
@@ -22,6 +22,7 @@
     <p:sldId id="270" r:id="rId21"/>
     <p:sldId id="271" r:id="rId22"/>
     <p:sldId id="272" r:id="rId23"/>
+    <p:sldId id="273" r:id="rId24"/>
   </p:sldIdLst>
   <p:sldSz cx="12191695" cy="6858000" type="screen4x3"/>
   <p:notesSz cx="6858000" cy="9144000"/>
@@ -5874,45 +5875,6 @@
           </a:p>
         </p:txBody>
       </p:sp>
-      <p:sp>
-        <p:nvSpPr>
-          <p:cNvPr id="6" name="TextBox 5"/>
-          <p:cNvSpPr txBox="1"/>
-          <p:nvPr/>
-        </p:nvSpPr>
-        <p:spPr>
-          <a:xfrm>
-            <a:off x="411480" y="4474845"/>
-            <a:ext cx="11368735" cy="274320"/>
-          </a:xfrm>
-          <a:prstGeom prst="rect">
-            <a:avLst/>
-          </a:prstGeom>
-          <a:noFill/>
-        </p:spPr>
-        <p:txBody>
-          <a:bodyPr wrap="square">
-            <a:spAutoFit/>
-          </a:bodyPr>
-          <a:lstStyle/>
-          <a:p>
-            <a:pPr>
-              <a:spcAft>
-                <a:spcPts val="600"/>
-              </a:spcAft>
-            </a:pPr>
-            <a:r>
-              <a:rPr sz="1500" b="0">
-                <a:solidFill>
-                  <a:srgbClr val="282828"/>
-                </a:solidFill>
-                <a:latin typeface="Arial"/>
-              </a:rPr>
-              <a:t># Backup</a:t>
-            </a:r>
-          </a:p>
-        </p:txBody>
-      </p:sp>
     </p:spTree>
   </p:cSld>
   <p:clrMapOvr>
@@ -5922,6 +5884,63 @@
 </file>
 
 <file path=ppt/slides/slide17.xml><?xml version="1.0" encoding="utf-8"?>
+<p:sld xmlns:a="http://schemas.openxmlformats.org/drawingml/2006/main" xmlns:p="http://schemas.openxmlformats.org/presentationml/2006/main" xmlns:r="http://schemas.openxmlformats.org/officeDocument/2006/relationships">
+  <p:cSld>
+    <p:spTree>
+      <p:nvGrpSpPr>
+        <p:cNvPr id="1" name=""/>
+        <p:cNvGrpSpPr/>
+        <p:nvPr/>
+      </p:nvGrpSpPr>
+      <p:grpSpPr/>
+      <p:sp>
+        <p:nvSpPr>
+          <p:cNvPr id="2" name="TextBox 1"/>
+          <p:cNvSpPr txBox="1"/>
+          <p:nvPr/>
+        </p:nvSpPr>
+        <p:spPr>
+          <a:xfrm>
+            <a:off x="822960" y="2743200"/>
+            <a:ext cx="10545775" cy="1280160"/>
+          </a:xfrm>
+          <a:prstGeom prst="rect">
+            <a:avLst/>
+          </a:prstGeom>
+          <a:noFill/>
+        </p:spPr>
+        <p:txBody>
+          <a:bodyPr wrap="square">
+            <a:spAutoFit/>
+          </a:bodyPr>
+          <a:lstStyle/>
+          <a:p>
+            <a:pPr algn="ctr">
+              <a:spcAft>
+                <a:spcPts val="400"/>
+              </a:spcAft>
+            </a:pPr>
+            <a:r>
+              <a:rPr sz="4000" b="1">
+                <a:solidFill>
+                  <a:srgbClr val="1F4E79"/>
+                </a:solidFill>
+                <a:latin typeface="Arial"/>
+              </a:rPr>
+              <a:t>Backup</a:t>
+            </a:r>
+          </a:p>
+        </p:txBody>
+      </p:sp>
+    </p:spTree>
+  </p:cSld>
+  <p:clrMapOvr>
+    <a:masterClrMapping/>
+  </p:clrMapOvr>
+</p:sld>
+</file>
+
+<file path=ppt/slides/slide18.xml><?xml version="1.0" encoding="utf-8"?>
 <p:sld xmlns:a="http://schemas.openxmlformats.org/drawingml/2006/main" xmlns:p="http://schemas.openxmlformats.org/presentationml/2006/main" xmlns:r="http://schemas.openxmlformats.org/officeDocument/2006/relationships">
   <p:cSld>
     <p:spTree>

</xml_diff>

<commit_message>
decks: WF-estimate triptychs + traced-rig renders in both DM-gauge decks
Per Dave 2026-09-04: both decks now carry applied/sensed/error
graphics for the two example classes (single-actuator poke, defocus)
and clean traced renders of the benches (view_rx, the cube-rig style).
- deck_tg_fang (19 slides): TG96 layout slide swaps the ribbon for
  the traced render; new 'Wavefront estimates through the gauge'
  slide (poke 0.984/0.049 nm, defocus 1.024/0.086 nm).
- deck_zwfs (10 slides): setup slide gets the traced render; new
  'Measuring the DM' slide (poke 0.445 at the sampling-starved
  camera -- caveat stated; defocus 0.986); the earlier 'defocus 0.32'
  claim CORRECTED throughout (pattern-radius artifact; correction
  trail in backup + campaign README).

Co-Authored-By: Claude Fable 5 <noreply@anthropic.com>
</commit_message>
<xml_diff>
--- a/demo_session/deck_tg_fang.pptx
+++ b/demo_session/deck_tg_fang.pptx
@@ -23,6 +23,7 @@
     <p:sldId id="271" r:id="rId22"/>
     <p:sldId id="272" r:id="rId23"/>
     <p:sldId id="273" r:id="rId24"/>
+    <p:sldId id="274" r:id="rId25"/>
   </p:sldIdLst>
   <p:sldSz cx="12191695" cy="6858000" type="screen4x3"/>
   <p:notesSz cx="6858000" cy="9144000"/>
@@ -4371,7 +4372,7 @@
       </p:sp>
       <p:pic>
         <p:nvPicPr>
-          <p:cNvPr id="5" name="Picture 4" descr="tg96_layout.png"/>
+          <p:cNvPr id="5" name="Picture 4" descr="tg96_render_rig.png"/>
           <p:cNvPicPr>
             <a:picLocks noChangeAspect="1"/>
           </p:cNvPicPr>
@@ -4385,8 +4386,8 @@
         </p:blipFill>
         <p:spPr>
           <a:xfrm>
-            <a:off x="7252582" y="1298448"/>
-            <a:ext cx="3691394" cy="2514092"/>
+            <a:off x="6503663" y="1298448"/>
+            <a:ext cx="5189233" cy="1708912"/>
           </a:xfrm>
           <a:prstGeom prst="rect">
             <a:avLst/>
@@ -4401,8 +4402,8 @@
         </p:nvSpPr>
         <p:spPr>
           <a:xfrm>
-            <a:off x="6400800" y="3830827"/>
-            <a:ext cx="5394960" cy="229107"/>
+            <a:off x="6400800" y="3025648"/>
+            <a:ext cx="5394960" cy="394208"/>
           </a:xfrm>
           <a:prstGeom prst="rect">
             <a:avLst/>
@@ -4427,7 +4428,7 @@
                 </a:solidFill>
                 <a:latin typeface="Arial"/>
               </a:rPr>
-              <a:t>The solved bench: plate at 7°, DM leg 700 mm, every beam-edge margin ≥ 25 mm.</a:t>
+              <a:t>The test arm as traced: plate at 7°, the 96 mm DM on its 700 mm leg, and the detector tail to the pupil-image camera.</a:t>
             </a:r>
           </a:p>
         </p:txBody>
@@ -4440,7 +4441,7 @@
         </p:nvSpPr>
         <p:spPr>
           <a:xfrm>
-            <a:off x="6400800" y="4096511"/>
+            <a:off x="6400800" y="3456432"/>
             <a:ext cx="5394960" cy="274320"/>
           </a:xfrm>
           <a:prstGeom prst="rect">
@@ -4466,7 +4467,7 @@
                 </a:solidFill>
                 <a:latin typeface="Arial"/>
               </a:rPr>
-              <a:t>Record: templates/90_polarization/tg_psi_dm96 (tg96.m; report, layout and figures committed).</a:t>
+              <a:t>Record: templates/40_benches/tg_psi_dm96 (tg96.m; report, clearance-margin layout figure, and all numbers committed).</a:t>
             </a:r>
           </a:p>
         </p:txBody>
@@ -4786,6 +4787,327 @@
 </file>
 
 <file path=ppt/slides/slide15.xml><?xml version="1.0" encoding="utf-8"?>
+<p:sld xmlns:a="http://schemas.openxmlformats.org/drawingml/2006/main" xmlns:p="http://schemas.openxmlformats.org/presentationml/2006/main" xmlns:r="http://schemas.openxmlformats.org/officeDocument/2006/relationships">
+  <p:cSld>
+    <p:spTree>
+      <p:nvGrpSpPr>
+        <p:cNvPr id="1" name=""/>
+        <p:cNvGrpSpPr/>
+        <p:nvPr/>
+      </p:nvGrpSpPr>
+      <p:grpSpPr/>
+      <p:sp>
+        <p:nvSpPr>
+          <p:cNvPr id="2" name="TextBox 1"/>
+          <p:cNvSpPr txBox="1"/>
+          <p:nvPr/>
+        </p:nvSpPr>
+        <p:spPr>
+          <a:xfrm>
+            <a:off x="411480" y="201168"/>
+            <a:ext cx="11368735" cy="914400"/>
+          </a:xfrm>
+          <a:prstGeom prst="rect">
+            <a:avLst/>
+          </a:prstGeom>
+          <a:noFill/>
+        </p:spPr>
+        <p:txBody>
+          <a:bodyPr wrap="square">
+            <a:spAutoFit/>
+          </a:bodyPr>
+          <a:lstStyle/>
+          <a:p>
+            <a:pPr>
+              <a:spcAft>
+                <a:spcPts val="400"/>
+              </a:spcAft>
+            </a:pPr>
+            <a:r>
+              <a:rPr sz="2400" b="1">
+                <a:solidFill>
+                  <a:srgbClr val="1F4E79"/>
+                </a:solidFill>
+                <a:latin typeface="Arial"/>
+              </a:rPr>
+              <a:t>Wavefront estimates through the gauge</a:t>
+            </a:r>
+          </a:p>
+          <a:p>
+            <a:pPr>
+              <a:spcAft>
+                <a:spcPts val="0"/>
+              </a:spcAft>
+            </a:pPr>
+            <a:r>
+              <a:rPr sz="1250" b="0">
+                <a:solidFill>
+                  <a:srgbClr val="6E6E6E"/>
+                </a:solidFill>
+                <a:latin typeface="Arial"/>
+              </a:rPr>
+              <a:t>One actuator pushed 20 nm recovers at gain 0.98 with 0.05 nm rms error; an 8 nm defocus at 1.02 with 0.09 nm — applied, sensed, and the estimate error</a:t>
+            </a:r>
+          </a:p>
+        </p:txBody>
+      </p:sp>
+      <p:sp>
+        <p:nvSpPr>
+          <p:cNvPr id="3" name="Rectangle 2"/>
+          <p:cNvSpPr/>
+          <p:nvPr/>
+        </p:nvSpPr>
+        <p:spPr>
+          <a:xfrm>
+            <a:off x="411480" y="1133856"/>
+            <a:ext cx="11368735" cy="20320"/>
+          </a:xfrm>
+          <a:prstGeom prst="rect">
+            <a:avLst/>
+          </a:prstGeom>
+          <a:solidFill>
+            <a:srgbClr val="B8C6D4"/>
+          </a:solidFill>
+          <a:ln>
+            <a:noFill/>
+          </a:ln>
+          <a:effectLst/>
+        </p:spPr>
+        <p:style>
+          <a:lnRef idx="1">
+            <a:schemeClr val="accent1"/>
+          </a:lnRef>
+          <a:fillRef idx="3">
+            <a:schemeClr val="accent1"/>
+          </a:fillRef>
+          <a:effectRef idx="2">
+            <a:schemeClr val="accent1"/>
+          </a:effectRef>
+          <a:fontRef idx="minor">
+            <a:schemeClr val="lt1"/>
+          </a:fontRef>
+        </p:style>
+        <p:txBody>
+          <a:bodyPr rtlCol="0" anchor="ctr"/>
+          <a:lstStyle/>
+          <a:p>
+            <a:pPr algn="ctr"/>
+          </a:p>
+        </p:txBody>
+      </p:sp>
+      <p:pic>
+        <p:nvPicPr>
+          <p:cNvPr id="4" name="Picture 3" descr="tg96_poke_triptych.png"/>
+          <p:cNvPicPr>
+            <a:picLocks noChangeAspect="1"/>
+          </p:cNvPicPr>
+          <p:nvPr/>
+        </p:nvPicPr>
+        <p:blipFill>
+          <a:blip r:embed="rId2"/>
+          <a:stretch>
+            <a:fillRect/>
+          </a:stretch>
+        </p:blipFill>
+        <p:spPr>
+          <a:xfrm>
+            <a:off x="3643334" y="1298448"/>
+            <a:ext cx="4905026" cy="1462532"/>
+          </a:xfrm>
+          <a:prstGeom prst="rect">
+            <a:avLst/>
+          </a:prstGeom>
+        </p:spPr>
+      </p:pic>
+      <p:sp>
+        <p:nvSpPr>
+          <p:cNvPr id="5" name="TextBox 4"/>
+          <p:cNvSpPr txBox="1"/>
+          <p:nvPr/>
+        </p:nvSpPr>
+        <p:spPr>
+          <a:xfrm>
+            <a:off x="411480" y="2779268"/>
+            <a:ext cx="11368735" cy="229107"/>
+          </a:xfrm>
+          <a:prstGeom prst="rect">
+            <a:avLst/>
+          </a:prstGeom>
+          <a:noFill/>
+        </p:spPr>
+        <p:txBody>
+          <a:bodyPr wrap="square">
+            <a:spAutoFit/>
+          </a:bodyPr>
+          <a:lstStyle/>
+          <a:p>
+            <a:pPr algn="ctr">
+              <a:spcAft>
+                <a:spcPts val="0"/>
+              </a:spcAft>
+            </a:pPr>
+            <a:r>
+              <a:rPr sz="1000" b="0">
+                <a:solidFill>
+                  <a:srgbClr val="6E6E6E"/>
+                </a:solidFill>
+                <a:latin typeface="Arial"/>
+              </a:rPr>
+              <a:t>One actuator pushed 20 nm: sensed matches applied; the error is a 0.05 nm rms sub-actuator dipole (residual registration, not gauge phase).</a:t>
+            </a:r>
+          </a:p>
+        </p:txBody>
+      </p:sp>
+      <p:pic>
+        <p:nvPicPr>
+          <p:cNvPr id="6" name="Picture 5" descr="tg96_defocus_triptych.png"/>
+          <p:cNvPicPr>
+            <a:picLocks noChangeAspect="1"/>
+          </p:cNvPicPr>
+          <p:nvPr/>
+        </p:nvPicPr>
+        <p:blipFill>
+          <a:blip r:embed="rId3"/>
+          <a:stretch>
+            <a:fillRect/>
+          </a:stretch>
+        </p:blipFill>
+        <p:spPr>
+          <a:xfrm>
+            <a:off x="3635414" y="3044952"/>
+            <a:ext cx="4920865" cy="1462532"/>
+          </a:xfrm>
+          <a:prstGeom prst="rect">
+            <a:avLst/>
+          </a:prstGeom>
+        </p:spPr>
+      </p:pic>
+      <p:sp>
+        <p:nvSpPr>
+          <p:cNvPr id="7" name="TextBox 6"/>
+          <p:cNvSpPr txBox="1"/>
+          <p:nvPr/>
+        </p:nvSpPr>
+        <p:spPr>
+          <a:xfrm>
+            <a:off x="411480" y="4525771"/>
+            <a:ext cx="11368735" cy="229107"/>
+          </a:xfrm>
+          <a:prstGeom prst="rect">
+            <a:avLst/>
+          </a:prstGeom>
+          <a:noFill/>
+        </p:spPr>
+        <p:txBody>
+          <a:bodyPr wrap="square">
+            <a:spAutoFit/>
+          </a:bodyPr>
+          <a:lstStyle/>
+          <a:p>
+            <a:pPr algn="ctr">
+              <a:spcAft>
+                <a:spcPts val="0"/>
+              </a:spcAft>
+            </a:pPr>
+            <a:r>
+              <a:rPr sz="1000" b="0">
+                <a:solidFill>
+                  <a:srgbClr val="6E6E6E"/>
+                </a:solidFill>
+                <a:latin typeface="Arial"/>
+              </a:rPr>
+              <a:t>Defocus at 8 nm amplitude: gain 1.024, error flat at 0.086 nm rms — the interferometer owns low order.</a:t>
+            </a:r>
+          </a:p>
+        </p:txBody>
+      </p:sp>
+      <p:sp>
+        <p:nvSpPr>
+          <p:cNvPr id="8" name="TextBox 7"/>
+          <p:cNvSpPr txBox="1"/>
+          <p:nvPr/>
+        </p:nvSpPr>
+        <p:spPr>
+          <a:xfrm>
+            <a:off x="411480" y="4791455"/>
+            <a:ext cx="11368735" cy="274320"/>
+          </a:xfrm>
+          <a:prstGeom prst="rect">
+            <a:avLst/>
+          </a:prstGeom>
+          <a:noFill/>
+        </p:spPr>
+        <p:txBody>
+          <a:bodyPr wrap="square">
+            <a:spAutoFit/>
+          </a:bodyPr>
+          <a:lstStyle/>
+          <a:p>
+            <a:pPr>
+              <a:spcAft>
+                <a:spcPts val="600"/>
+              </a:spcAft>
+            </a:pPr>
+            <a:r>
+              <a:rPr sz="1500" b="0">
+                <a:solidFill>
+                  <a:srgbClr val="282828"/>
+                </a:solidFill>
+                <a:latin typeface="Arial"/>
+              </a:rPr>
+              <a:t>•  Reading with the transfer curve in hand: the gauge is essentially perfect from low order through the single-actuator scale; its cost concentrates at the finest patterns (0.50 gain at the full 96×96 checkerboard).  The same two cases measured on the Zernike sensor (its own deck): poke 0.45 at its sampling-starved camera, defocus 0.99.</a:t>
+            </a:r>
+          </a:p>
+        </p:txBody>
+      </p:sp>
+      <p:sp>
+        <p:nvSpPr>
+          <p:cNvPr id="9" name="TextBox 8"/>
+          <p:cNvSpPr txBox="1"/>
+          <p:nvPr/>
+        </p:nvSpPr>
+        <p:spPr>
+          <a:xfrm>
+            <a:off x="411480" y="5711189"/>
+            <a:ext cx="11368735" cy="274320"/>
+          </a:xfrm>
+          <a:prstGeom prst="rect">
+            <a:avLst/>
+          </a:prstGeom>
+          <a:noFill/>
+        </p:spPr>
+        <p:txBody>
+          <a:bodyPr wrap="square">
+            <a:spAutoFit/>
+          </a:bodyPr>
+          <a:lstStyle/>
+          <a:p>
+            <a:pPr>
+              <a:spcAft>
+                <a:spcPts val="600"/>
+              </a:spcAft>
+            </a:pPr>
+            <a:r>
+              <a:rPr sz="1050" b="0">
+                <a:solidFill>
+                  <a:srgbClr val="6E6E6E"/>
+                </a:solidFill>
+                <a:latin typeface="Arial"/>
+              </a:rPr>
+              <a:t>Truth mapped to the camera by traced rays; measurement sign −1 and patterns on the illuminated 38 mm radius (the source fills 74% of the aperture — a display-frame lesson recorded in the campaign README).  Record: tg96_wf_figs.m.</a:t>
+            </a:r>
+          </a:p>
+        </p:txBody>
+      </p:sp>
+    </p:spTree>
+  </p:cSld>
+  <p:clrMapOvr>
+    <a:masterClrMapping/>
+  </p:clrMapOvr>
+</p:sld>
+</file>
+
+<file path=ppt/slides/slide16.xml><?xml version="1.0" encoding="utf-8"?>
 <p:sld xmlns:a="http://schemas.openxmlformats.org/drawingml/2006/main" xmlns:p="http://schemas.openxmlformats.org/presentationml/2006/main" xmlns:r="http://schemas.openxmlformats.org/officeDocument/2006/relationships">
   <p:cSld>
     <p:spTree>
@@ -5640,7 +5962,7 @@
 </p:sld>
 </file>
 
-<file path=ppt/slides/slide16.xml><?xml version="1.0" encoding="utf-8"?>
+<file path=ppt/slides/slide17.xml><?xml version="1.0" encoding="utf-8"?>
 <p:sld xmlns:a="http://schemas.openxmlformats.org/drawingml/2006/main" xmlns:p="http://schemas.openxmlformats.org/presentationml/2006/main" xmlns:r="http://schemas.openxmlformats.org/officeDocument/2006/relationships">
   <p:cSld>
     <p:spTree>
@@ -5871,63 +6193,6 @@
                 <a:latin typeface="Arial"/>
               </a:rPr>
               <a:t>All records, checks and figures are committed and re-runnable; the full demonstration runs in under a minute of compute.</a:t>
-            </a:r>
-          </a:p>
-        </p:txBody>
-      </p:sp>
-    </p:spTree>
-  </p:cSld>
-  <p:clrMapOvr>
-    <a:masterClrMapping/>
-  </p:clrMapOvr>
-</p:sld>
-</file>
-
-<file path=ppt/slides/slide17.xml><?xml version="1.0" encoding="utf-8"?>
-<p:sld xmlns:a="http://schemas.openxmlformats.org/drawingml/2006/main" xmlns:p="http://schemas.openxmlformats.org/presentationml/2006/main" xmlns:r="http://schemas.openxmlformats.org/officeDocument/2006/relationships">
-  <p:cSld>
-    <p:spTree>
-      <p:nvGrpSpPr>
-        <p:cNvPr id="1" name=""/>
-        <p:cNvGrpSpPr/>
-        <p:nvPr/>
-      </p:nvGrpSpPr>
-      <p:grpSpPr/>
-      <p:sp>
-        <p:nvSpPr>
-          <p:cNvPr id="2" name="TextBox 1"/>
-          <p:cNvSpPr txBox="1"/>
-          <p:nvPr/>
-        </p:nvSpPr>
-        <p:spPr>
-          <a:xfrm>
-            <a:off x="822960" y="2743200"/>
-            <a:ext cx="10545775" cy="1280160"/>
-          </a:xfrm>
-          <a:prstGeom prst="rect">
-            <a:avLst/>
-          </a:prstGeom>
-          <a:noFill/>
-        </p:spPr>
-        <p:txBody>
-          <a:bodyPr wrap="square">
-            <a:spAutoFit/>
-          </a:bodyPr>
-          <a:lstStyle/>
-          <a:p>
-            <a:pPr algn="ctr">
-              <a:spcAft>
-                <a:spcPts val="400"/>
-              </a:spcAft>
-            </a:pPr>
-            <a:r>
-              <a:rPr sz="4000" b="1">
-                <a:solidFill>
-                  <a:srgbClr val="1F4E79"/>
-                </a:solidFill>
-                <a:latin typeface="Arial"/>
-              </a:rPr>
-              <a:t>Backup</a:t>
             </a:r>
           </a:p>
         </p:txBody>
@@ -5958,6 +6223,63 @@
         </p:nvSpPr>
         <p:spPr>
           <a:xfrm>
+            <a:off x="822960" y="2743200"/>
+            <a:ext cx="10545775" cy="1280160"/>
+          </a:xfrm>
+          <a:prstGeom prst="rect">
+            <a:avLst/>
+          </a:prstGeom>
+          <a:noFill/>
+        </p:spPr>
+        <p:txBody>
+          <a:bodyPr wrap="square">
+            <a:spAutoFit/>
+          </a:bodyPr>
+          <a:lstStyle/>
+          <a:p>
+            <a:pPr algn="ctr">
+              <a:spcAft>
+                <a:spcPts val="400"/>
+              </a:spcAft>
+            </a:pPr>
+            <a:r>
+              <a:rPr sz="4000" b="1">
+                <a:solidFill>
+                  <a:srgbClr val="1F4E79"/>
+                </a:solidFill>
+                <a:latin typeface="Arial"/>
+              </a:rPr>
+              <a:t>Backup</a:t>
+            </a:r>
+          </a:p>
+        </p:txBody>
+      </p:sp>
+    </p:spTree>
+  </p:cSld>
+  <p:clrMapOvr>
+    <a:masterClrMapping/>
+  </p:clrMapOvr>
+</p:sld>
+</file>
+
+<file path=ppt/slides/slide19.xml><?xml version="1.0" encoding="utf-8"?>
+<p:sld xmlns:a="http://schemas.openxmlformats.org/drawingml/2006/main" xmlns:p="http://schemas.openxmlformats.org/presentationml/2006/main" xmlns:r="http://schemas.openxmlformats.org/officeDocument/2006/relationships">
+  <p:cSld>
+    <p:spTree>
+      <p:nvGrpSpPr>
+        <p:cNvPr id="1" name=""/>
+        <p:cNvGrpSpPr/>
+        <p:nvPr/>
+      </p:nvGrpSpPr>
+      <p:grpSpPr/>
+      <p:sp>
+        <p:nvSpPr>
+          <p:cNvPr id="2" name="TextBox 1"/>
+          <p:cNvSpPr txBox="1"/>
+          <p:nvPr/>
+        </p:nvSpPr>
+        <p:spPr>
+          <a:xfrm>
             <a:off x="411480" y="201168"/>
             <a:ext cx="11368735" cy="914400"/>
           </a:xfrm>
@@ -6115,7 +6437,7 @@
                 </a:solidFill>
                 <a:latin typeface="Arial"/>
               </a:rPr>
-              <a:t>•  96×96 realization: templates/90_polarization/tg_psi_dm96 — tg96.m (clearance solve, sampling budget, build, battery, response curve, differential test), tg96_tail.m (detector-leg re-optimization: null 9.11 → 0.134 nm, found at reduced resolution, verified at full), tg96_report.txt (all numbers on the 96×96 slides), plus the preserved registration failure series (six reports).</a:t>
+              <a:t>•  96×96 realization: templates/40_benches/tg_psi_dm96 — tg96.m (clearance solve, sampling budget, build, battery, response curve, differential test), tg96_tail.m (detector-leg re-optimization: null 9.11 → 0.134 nm, found at reduced resolution, verified at full), tg96_report.txt (all numbers on the 96×96 slides), plus the preserved registration failure series (six reports).</a:t>
             </a:r>
           </a:p>
           <a:p>

</xml_diff>

<commit_message>
decks: the multi-color excursion (S6) folded into deck_tg_fang (23 slides) and deck_zwfs (11 slides)
deck_tg_fang: one slide after the photon pricing -- "Color moves the
sensor's blind bands, not the interferometer's" (both transfer panels,
the 3-4x floor gain and the geometric-roll-off diagnosis); the
modeling-assumptions, open-items and provenance bullets updated.
deck_zwfs: "Color as a lever" slide after the poke/defocus slide; title
status line and the head-to-head footnote note the S2-S5 results now in
the interferometer deck.  Figure panels cropped from the committed
zwfs_s6color.png (suptitle removed, split at the gutter).  Style gate
clean; both decks remain DRAFT, no export mark.

Co-Authored-By: Claude Fable 5.1 <noreply@anthropic.com>
</commit_message>
<xml_diff>
--- a/demo_session/deck_tg_fang.pptx
+++ b/demo_session/deck_tg_fang.pptx
@@ -27,6 +27,7 @@
     <p:sldId id="275" r:id="rId26"/>
     <p:sldId id="276" r:id="rId27"/>
     <p:sldId id="277" r:id="rId28"/>
+    <p:sldId id="278" r:id="rId29"/>
   </p:sldIdLst>
   <p:sldSz cx="12191695" cy="6858000" type="screen4x3"/>
   <p:notesSz cx="6858000" cy="9144000"/>
@@ -6673,7 +6674,7 @@
                 </a:solidFill>
                 <a:latin typeface="Arial"/>
               </a:rPr>
-              <a:t>•  The mask is a complex transmission applied to the propagated field at focus — not a phase screen on rays: 346.2 nm etch in fused silica (π/2 at 632.8 nm, the VSG2 hardware value), gray-edge supersampled disk, diameter 2.0 λ/D as used (1.06 λ/D — the hardware spot — sign-inverts the fine-actuator band; the spot is a band-select lever we measured, not a free parameter).</a:t>
+              <a:t>•  The mask is a complex transmission applied to the propagated field at focus — not a phase screen on rays: 346.2 nm etch in fused silica (π/2 at 632.8 nm, the VSG2 hardware value), gray-edge supersampled disk, diameter 2.0 λ/D as used (1.06 λ/D — the hardware spot — sign-inverts the fine-actuator band; the spot is a band-select lever we measured, not a free parameter); the mask is fixed glass, so its phase and λ/D diameter scale with wavelength — the multi-color slide.</a:t>
             </a:r>
           </a:p>
           <a:p>
@@ -7656,7 +7657,7 @@
                 </a:solidFill>
                 <a:latin typeface="Arial"/>
               </a:rPr>
-              <a:t>What this offers a bench program</a:t>
+              <a:t>Color moves the sensor's blind bands, not the interferometer's</a:t>
             </a:r>
           </a:p>
           <a:p>
@@ -7672,7 +7673,7 @@
                 </a:solidFill>
                 <a:latin typeface="Arial"/>
               </a:rPr>
-              <a:t>An instrument-error sandbox where truth is exact and every systematic prints</a:t>
+              <a:t>Five colors, 480–780 nm, lift the sensor's floors 3–4× and halve its dense-random error; every interferometer number holds to three digits</a:t>
             </a:r>
           </a:p>
         </p:txBody>
@@ -7721,16 +7722,40 @@
           </a:p>
         </p:txBody>
       </p:sp>
-      <p:sp>
-        <p:nvSpPr>
-          <p:cNvPr id="4" name="TextBox 3"/>
+      <p:pic>
+        <p:nvPicPr>
+          <p:cNvPr id="4" name="Picture 3" descr="crop_zwfs_s6color_zwfs.png"/>
+          <p:cNvPicPr>
+            <a:picLocks noChangeAspect="1"/>
+          </p:cNvPicPr>
+          <p:nvPr/>
+        </p:nvPicPr>
+        <p:blipFill>
+          <a:blip r:embed="rId2"/>
+          <a:stretch>
+            <a:fillRect/>
+          </a:stretch>
+        </p:blipFill>
+        <p:spPr>
+          <a:xfrm>
+            <a:off x="1826947" y="1298448"/>
+            <a:ext cx="2975504" cy="2531872"/>
+          </a:xfrm>
+          <a:prstGeom prst="rect">
+            <a:avLst/>
+          </a:prstGeom>
+        </p:spPr>
+      </p:pic>
+      <p:sp>
+        <p:nvSpPr>
+          <p:cNvPr id="5" name="TextBox 4"/>
           <p:cNvSpPr txBox="1"/>
           <p:nvPr/>
         </p:nvSpPr>
         <p:spPr>
           <a:xfrm>
-            <a:off x="411480" y="1298448"/>
-            <a:ext cx="11368735" cy="274320"/>
+            <a:off x="411480" y="3848608"/>
+            <a:ext cx="5806440" cy="394208"/>
           </a:xfrm>
           <a:prstGeom prst="rect">
             <a:avLst/>
@@ -7743,81 +7768,57 @@
           </a:bodyPr>
           <a:lstStyle/>
           <a:p>
-            <a:pPr>
-              <a:spcAft>
-                <a:spcPts val="600"/>
-              </a:spcAft>
-            </a:pPr>
-            <a:r>
-              <a:rPr sz="1500" b="0">
-                <a:solidFill>
-                  <a:srgbClr val="282828"/>
-                </a:solidFill>
-                <a:latin typeface="Arial"/>
-              </a:rPr>
-              <a:t>•  Catch the invisible class before hardware does: the plate rig's 11.7% scale error moved contrast 0.17% — found on first closure in the model, because the model has the truth panel a bench lacks.</a:t>
-            </a:r>
-          </a:p>
-          <a:p>
-            <a:pPr>
-              <a:spcAft>
-                <a:spcPts val="600"/>
-              </a:spcAft>
-            </a:pPr>
-            <a:r>
-              <a:rPr sz="1500" b="0">
-                <a:solidFill>
-                  <a:srgbClr val="282828"/>
-                </a:solidFill>
-                <a:latin typeface="Arial"/>
-              </a:rPr>
-              <a:t>•  Price hardware choices in instrument terms: the three-option table is the pattern — splitter angle, cube against plate, waveplate tolerances, coating terminations, analyzer options (rotating or pixelated) all price the same way.</a:t>
-            </a:r>
-          </a:p>
-          <a:p>
-            <a:pPr>
-              <a:spcAft>
-                <a:spcPts val="600"/>
-              </a:spcAft>
-            </a:pPr>
-            <a:r>
-              <a:rPr sz="1500" b="0">
-                <a:solidFill>
-                  <a:srgbClr val="282828"/>
-                </a:solidFill>
-                <a:latin typeface="Arial"/>
-              </a:rPr>
-              <a:t>•  Rehearse calibration protocols: the low-order and actuator-scale calibrations are scripts; a planned bench protocol can run against the model first, with injected errors of chosen size.</a:t>
-            </a:r>
-          </a:p>
-          <a:p>
-            <a:pPr>
-              <a:spcAft>
-                <a:spcPts val="600"/>
-              </a:spcAft>
-            </a:pPr>
-            <a:r>
-              <a:rPr sz="1500" b="0">
-                <a:solidFill>
-                  <a:srgbClr val="282828"/>
-                </a:solidFill>
-                <a:latin typeface="Arial"/>
-              </a:rPr>
-              <a:t>•  What the model does not yet carry: source noise, detector noise, vibration and drift — the idealized gauge is the systematic-error floor, not a bench prediction.  Adding measured-class realism is the natural next step, sized to a use case.</a:t>
-            </a:r>
-          </a:p>
-        </p:txBody>
-      </p:sp>
-      <p:sp>
-        <p:nvSpPr>
-          <p:cNvPr id="5" name="TextBox 4"/>
+            <a:pPr algn="ctr">
+              <a:spcAft>
+                <a:spcPts val="0"/>
+              </a:spcAft>
+            </a:pPr>
+            <a:r>
+              <a:rPr sz="1000" b="0">
+                <a:solidFill>
+                  <a:srgbClr val="6E6E6E"/>
+                </a:solidFill>
+                <a:latin typeface="Arial"/>
+              </a:rPr>
+              <a:t>Zernike sensor: the transfer null near 30 cycles/pupil at 632.8 nm sits at 40 cycles at 480 nm and at 20 at 780 nm; the five-color combination (black) stays above 0.99.</a:t>
+            </a:r>
+          </a:p>
+        </p:txBody>
+      </p:sp>
+      <p:pic>
+        <p:nvPicPr>
+          <p:cNvPr id="6" name="Picture 5" descr="crop_zwfs_s6color_ifo.png"/>
+          <p:cNvPicPr>
+            <a:picLocks noChangeAspect="1"/>
+          </p:cNvPicPr>
+          <p:nvPr/>
+        </p:nvPicPr>
+        <p:blipFill>
+          <a:blip r:embed="rId3"/>
+          <a:stretch>
+            <a:fillRect/>
+          </a:stretch>
+        </p:blipFill>
+        <p:spPr>
+          <a:xfrm>
+            <a:off x="7618449" y="1298448"/>
+            <a:ext cx="2959660" cy="2531872"/>
+          </a:xfrm>
+          <a:prstGeom prst="rect">
+            <a:avLst/>
+          </a:prstGeom>
+        </p:spPr>
+      </p:pic>
+      <p:sp>
+        <p:nvSpPr>
+          <p:cNvPr id="7" name="TextBox 6"/>
           <p:cNvSpPr txBox="1"/>
           <p:nvPr/>
         </p:nvSpPr>
         <p:spPr>
           <a:xfrm>
-            <a:off x="411480" y="4124706"/>
-            <a:ext cx="11368735" cy="274320"/>
+            <a:off x="6400800" y="3848608"/>
+            <a:ext cx="5394960" cy="394208"/>
           </a:xfrm>
           <a:prstGeom prst="rect">
             <a:avLst/>
@@ -7830,19 +7831,113 @@
           </a:bodyPr>
           <a:lstStyle/>
           <a:p>
+            <a:pPr algn="ctr">
+              <a:spcAft>
+                <a:spcPts val="0"/>
+              </a:spcAft>
+            </a:pPr>
+            <a:r>
+              <a:rPr sz="1000" b="0">
+                <a:solidFill>
+                  <a:srgbClr val="6E6E6E"/>
+                </a:solidFill>
+                <a:latin typeface="Arial"/>
+              </a:rPr>
+              <a:t>Interferometer: the five colors coincide (spread 0.004 in gain) — the roll-off is not diffraction.</a:t>
+            </a:r>
+          </a:p>
+        </p:txBody>
+      </p:sp>
+      <p:sp>
+        <p:nvSpPr>
+          <p:cNvPr id="8" name="TextBox 7"/>
+          <p:cNvSpPr txBox="1"/>
+          <p:nvPr/>
+        </p:nvSpPr>
+        <p:spPr>
+          <a:xfrm>
+            <a:off x="411480" y="4279392"/>
+            <a:ext cx="11368735" cy="274320"/>
+          </a:xfrm>
+          <a:prstGeom prst="rect">
+            <a:avLst/>
+          </a:prstGeom>
+          <a:noFill/>
+        </p:spPr>
+        <p:txBody>
+          <a:bodyPr wrap="square">
+            <a:spAutoFit/>
+          </a:bodyPr>
+          <a:lstStyle/>
+          <a:p>
             <a:pPr>
               <a:spcAft>
                 <a:spcPts val="600"/>
               </a:spcAft>
             </a:pPr>
             <a:r>
+              <a:rPr sz="1500" b="0">
+                <a:solidFill>
+                  <a:srgbClr val="282828"/>
+                </a:solidFill>
+                <a:latin typeface="Arial"/>
+              </a:rPr>
+              <a:t>•  Sensor: the dimple is fixed glass — its phase and λ/D size scale with wavelength, so no two colors are blind at the same frequency, and a multi-channel Wiener estimate on the actuator lattice carries each mode with the colors that see it.  On the 30 nm working surface: single-actuator floor 720 → 224 pm (SNR 9 → 35), dense random 16.4 → 7.2 nm; the undetected grid case (47 actuators at 1 nm) rises from SNR 1.5 to 3.4 — still short of 5.</a:t>
+            </a:r>
+          </a:p>
+          <a:p>
+            <a:pPr>
+              <a:spcAft>
+                <a:spcPts val="600"/>
+              </a:spcAft>
+            </a:pPr>
+            <a:r>
+              <a:rPr sz="1500" b="0">
+                <a:solidFill>
+                  <a:srgbClr val="282828"/>
+                </a:solidFill>
+                <a:latin typeface="Arial"/>
+              </a:rPr>
+              <a:t>•  Interferometer: 92 pm hold-out, 4.17 nm dense random, SNR 210 at every color and after combination.  A diffraction roll-off would have moved 1.6× across this band; it moved under 0.3%: the loss is geometric (the null-tuned detector leg's conjugate and 0.14 mm of warp), so the joint leg optimization is the lever, not the source.</a:t>
+            </a:r>
+          </a:p>
+        </p:txBody>
+      </p:sp>
+      <p:sp>
+        <p:nvSpPr>
+          <p:cNvPr id="9" name="TextBox 8"/>
+          <p:cNvSpPr txBox="1"/>
+          <p:nvPr/>
+        </p:nvSpPr>
+        <p:spPr>
+          <a:xfrm>
+            <a:off x="411480" y="6329933"/>
+            <a:ext cx="11368735" cy="274320"/>
+          </a:xfrm>
+          <a:prstGeom prst="rect">
+            <a:avLst/>
+          </a:prstGeom>
+          <a:noFill/>
+        </p:spPr>
+        <p:txBody>
+          <a:bodyPr wrap="square">
+            <a:spAutoFit/>
+          </a:bodyPr>
+          <a:lstStyle/>
+          <a:p>
+            <a:pPr>
+              <a:spcAft>
+                <a:spcPts val="600"/>
+              </a:spcAft>
+            </a:pPr>
+            <a:r>
               <a:rPr sz="1050" b="0">
                 <a:solidFill>
                   <a:srgbClr val="6E6E6E"/>
                 </a:solidFill>
                 <a:latin typeface="Arial"/>
               </a:rPr>
-              <a:t>All records, checks and figures are committed and re-runnable; the full demonstration runs in under a minute of compute.</a:t>
+              <a:t>One physical mask (346.2 nm etch, dispersion-corrected index), every calibration redone per color; achromatic quarter-wave plates and dispersionless lenses assumed; noiseless — K colors cost K× the frames.  Records: zwfs_s6color_report.txt, tg96_s6color_report.txt (96×96).</a:t>
             </a:r>
           </a:p>
         </p:txBody>
@@ -7873,8 +7968,8 @@
         </p:nvSpPr>
         <p:spPr>
           <a:xfrm>
-            <a:off x="822960" y="2743200"/>
-            <a:ext cx="10545775" cy="1280160"/>
+            <a:off x="411480" y="201168"/>
+            <a:ext cx="11368735" cy="914400"/>
           </a:xfrm>
           <a:prstGeom prst="rect">
             <a:avLst/>
@@ -7887,19 +7982,205 @@
           </a:bodyPr>
           <a:lstStyle/>
           <a:p>
-            <a:pPr algn="ctr">
+            <a:pPr>
               <a:spcAft>
                 <a:spcPts val="400"/>
               </a:spcAft>
             </a:pPr>
             <a:r>
-              <a:rPr sz="4000" b="1">
+              <a:rPr sz="2400" b="1">
                 <a:solidFill>
                   <a:srgbClr val="1F4E79"/>
                 </a:solidFill>
                 <a:latin typeface="Arial"/>
               </a:rPr>
-              <a:t>Backup</a:t>
+              <a:t>What this offers a bench program</a:t>
+            </a:r>
+          </a:p>
+          <a:p>
+            <a:pPr>
+              <a:spcAft>
+                <a:spcPts val="0"/>
+              </a:spcAft>
+            </a:pPr>
+            <a:r>
+              <a:rPr sz="1250" b="0">
+                <a:solidFill>
+                  <a:srgbClr val="6E6E6E"/>
+                </a:solidFill>
+                <a:latin typeface="Arial"/>
+              </a:rPr>
+              <a:t>An instrument-error sandbox where truth is exact and every systematic prints</a:t>
+            </a:r>
+          </a:p>
+        </p:txBody>
+      </p:sp>
+      <p:sp>
+        <p:nvSpPr>
+          <p:cNvPr id="3" name="Rectangle 2"/>
+          <p:cNvSpPr/>
+          <p:nvPr/>
+        </p:nvSpPr>
+        <p:spPr>
+          <a:xfrm>
+            <a:off x="411480" y="1133856"/>
+            <a:ext cx="11368735" cy="20320"/>
+          </a:xfrm>
+          <a:prstGeom prst="rect">
+            <a:avLst/>
+          </a:prstGeom>
+          <a:solidFill>
+            <a:srgbClr val="B8C6D4"/>
+          </a:solidFill>
+          <a:ln>
+            <a:noFill/>
+          </a:ln>
+          <a:effectLst/>
+        </p:spPr>
+        <p:style>
+          <a:lnRef idx="1">
+            <a:schemeClr val="accent1"/>
+          </a:lnRef>
+          <a:fillRef idx="3">
+            <a:schemeClr val="accent1"/>
+          </a:fillRef>
+          <a:effectRef idx="2">
+            <a:schemeClr val="accent1"/>
+          </a:effectRef>
+          <a:fontRef idx="minor">
+            <a:schemeClr val="lt1"/>
+          </a:fontRef>
+        </p:style>
+        <p:txBody>
+          <a:bodyPr rtlCol="0" anchor="ctr"/>
+          <a:lstStyle/>
+          <a:p>
+            <a:pPr algn="ctr"/>
+          </a:p>
+        </p:txBody>
+      </p:sp>
+      <p:sp>
+        <p:nvSpPr>
+          <p:cNvPr id="4" name="TextBox 3"/>
+          <p:cNvSpPr txBox="1"/>
+          <p:nvPr/>
+        </p:nvSpPr>
+        <p:spPr>
+          <a:xfrm>
+            <a:off x="411480" y="1298448"/>
+            <a:ext cx="11368735" cy="274320"/>
+          </a:xfrm>
+          <a:prstGeom prst="rect">
+            <a:avLst/>
+          </a:prstGeom>
+          <a:noFill/>
+        </p:spPr>
+        <p:txBody>
+          <a:bodyPr wrap="square">
+            <a:spAutoFit/>
+          </a:bodyPr>
+          <a:lstStyle/>
+          <a:p>
+            <a:pPr>
+              <a:spcAft>
+                <a:spcPts val="600"/>
+              </a:spcAft>
+            </a:pPr>
+            <a:r>
+              <a:rPr sz="1500" b="0">
+                <a:solidFill>
+                  <a:srgbClr val="282828"/>
+                </a:solidFill>
+                <a:latin typeface="Arial"/>
+              </a:rPr>
+              <a:t>•  Catch the invisible class before hardware does: the plate rig's 11.7% scale error moved contrast 0.17% — found on first closure in the model, because the model has the truth panel a bench lacks.</a:t>
+            </a:r>
+          </a:p>
+          <a:p>
+            <a:pPr>
+              <a:spcAft>
+                <a:spcPts val="600"/>
+              </a:spcAft>
+            </a:pPr>
+            <a:r>
+              <a:rPr sz="1500" b="0">
+                <a:solidFill>
+                  <a:srgbClr val="282828"/>
+                </a:solidFill>
+                <a:latin typeface="Arial"/>
+              </a:rPr>
+              <a:t>•  Price hardware choices in instrument terms: the three-option table is the pattern — splitter angle, cube against plate, waveplate tolerances, coating terminations, analyzer options (rotating or pixelated) all price the same way.</a:t>
+            </a:r>
+          </a:p>
+          <a:p>
+            <a:pPr>
+              <a:spcAft>
+                <a:spcPts val="600"/>
+              </a:spcAft>
+            </a:pPr>
+            <a:r>
+              <a:rPr sz="1500" b="0">
+                <a:solidFill>
+                  <a:srgbClr val="282828"/>
+                </a:solidFill>
+                <a:latin typeface="Arial"/>
+              </a:rPr>
+              <a:t>•  Rehearse calibration protocols: the low-order and actuator-scale calibrations are scripts; a planned bench protocol can run against the model first, with injected errors of chosen size.</a:t>
+            </a:r>
+          </a:p>
+          <a:p>
+            <a:pPr>
+              <a:spcAft>
+                <a:spcPts val="600"/>
+              </a:spcAft>
+            </a:pPr>
+            <a:r>
+              <a:rPr sz="1500" b="0">
+                <a:solidFill>
+                  <a:srgbClr val="282828"/>
+                </a:solidFill>
+                <a:latin typeface="Arial"/>
+              </a:rPr>
+              <a:t>•  What the model does not yet carry: source noise, detector noise, vibration and drift — the idealized gauge is the systematic-error floor, not a bench prediction.  Adding measured-class realism is the natural next step, sized to a use case.</a:t>
+            </a:r>
+          </a:p>
+        </p:txBody>
+      </p:sp>
+      <p:sp>
+        <p:nvSpPr>
+          <p:cNvPr id="5" name="TextBox 4"/>
+          <p:cNvSpPr txBox="1"/>
+          <p:nvPr/>
+        </p:nvSpPr>
+        <p:spPr>
+          <a:xfrm>
+            <a:off x="411480" y="4124706"/>
+            <a:ext cx="11368735" cy="274320"/>
+          </a:xfrm>
+          <a:prstGeom prst="rect">
+            <a:avLst/>
+          </a:prstGeom>
+          <a:noFill/>
+        </p:spPr>
+        <p:txBody>
+          <a:bodyPr wrap="square">
+            <a:spAutoFit/>
+          </a:bodyPr>
+          <a:lstStyle/>
+          <a:p>
+            <a:pPr>
+              <a:spcAft>
+                <a:spcPts val="600"/>
+              </a:spcAft>
+            </a:pPr>
+            <a:r>
+              <a:rPr sz="1050" b="0">
+                <a:solidFill>
+                  <a:srgbClr val="6E6E6E"/>
+                </a:solidFill>
+                <a:latin typeface="Arial"/>
+              </a:rPr>
+              <a:t>All records, checks and figures are committed and re-runnable; the full demonstration runs in under a minute of compute.</a:t>
             </a:r>
           </a:p>
         </p:txBody>
@@ -7930,6 +8211,63 @@
         </p:nvSpPr>
         <p:spPr>
           <a:xfrm>
+            <a:off x="822960" y="2743200"/>
+            <a:ext cx="10545775" cy="1280160"/>
+          </a:xfrm>
+          <a:prstGeom prst="rect">
+            <a:avLst/>
+          </a:prstGeom>
+          <a:noFill/>
+        </p:spPr>
+        <p:txBody>
+          <a:bodyPr wrap="square">
+            <a:spAutoFit/>
+          </a:bodyPr>
+          <a:lstStyle/>
+          <a:p>
+            <a:pPr algn="ctr">
+              <a:spcAft>
+                <a:spcPts val="400"/>
+              </a:spcAft>
+            </a:pPr>
+            <a:r>
+              <a:rPr sz="4000" b="1">
+                <a:solidFill>
+                  <a:srgbClr val="1F4E79"/>
+                </a:solidFill>
+                <a:latin typeface="Arial"/>
+              </a:rPr>
+              <a:t>Backup</a:t>
+            </a:r>
+          </a:p>
+        </p:txBody>
+      </p:sp>
+    </p:spTree>
+  </p:cSld>
+  <p:clrMapOvr>
+    <a:masterClrMapping/>
+  </p:clrMapOvr>
+</p:sld>
+</file>
+
+<file path=ppt/slides/slide23.xml><?xml version="1.0" encoding="utf-8"?>
+<p:sld xmlns:a="http://schemas.openxmlformats.org/drawingml/2006/main" xmlns:p="http://schemas.openxmlformats.org/presentationml/2006/main" xmlns:r="http://schemas.openxmlformats.org/officeDocument/2006/relationships">
+  <p:cSld>
+    <p:spTree>
+      <p:nvGrpSpPr>
+        <p:cNvPr id="1" name=""/>
+        <p:cNvGrpSpPr/>
+        <p:nvPr/>
+      </p:nvGrpSpPr>
+      <p:grpSpPr/>
+      <p:sp>
+        <p:nvSpPr>
+          <p:cNvPr id="2" name="TextBox 1"/>
+          <p:cNvSpPr txBox="1"/>
+          <p:nvPr/>
+        </p:nvSpPr>
+        <p:spPr>
+          <a:xfrm>
             <a:off x="411480" y="201168"/>
             <a:ext cx="11368735" cy="914400"/>
           </a:xfrm>
@@ -8135,7 +8473,7 @@
                 </a:solidFill>
                 <a:latin typeface="Arial"/>
               </a:rPr>
-              <a:t>•  Option-3 open items: joint detector-leg optimization (null + pupil-image sharpness + distortion together — the current leg tuned for null alone gave up finest-pattern gain 0.84 → 0.50), response-curve-corrected scoring of the differential residuals, decomposition of the sub-1% shallow-angle residuals (rig geometry against polarization), and a real splitter-coating design at shallow incidence.</a:t>
+              <a:t>•  Option-3 open items: joint detector-leg optimization (null + pupil-image sharpness + distortion together — the current leg tuned for null alone gave up finest-pattern gain 0.84 → 0.50; the multi-color run shows that loss is geometric, so the leg, not the source, is the lever), response-curve-corrected scoring of the differential residuals, decomposition of the sub-1% shallow-angle residuals (rig geometry against polarization), and a real splitter-coating design at shallow incidence.</a:t>
             </a:r>
           </a:p>
           <a:p>
@@ -8151,7 +8489,7 @@
                 </a:solidFill>
                 <a:latin typeface="Arial"/>
               </a:rPr>
-              <a:t>•  Head-to-head campaign records (both instruments, one scoring library): templates/40_benches/dm_gauge_lib (registration / actuator fit / modal correction / both measurement factories; the two S3 batteries re-run identically through it as the equivalence gate) + tg_psi_dm96 and zwfs_dm96 stage reports S2–S5 (registration and kernel calibration, modal battery, differential head-to-head with break scale, photon-noise pricing).  Campaign READMEs carry the findings ledgers, including the corrected attributions (pattern-radius frame bias; the refuted sampling-starvation hypothesis).</a:t>
+              <a:t>•  Head-to-head campaign records (both instruments, one scoring library): templates/40_benches/dm_gauge_lib (registration / actuator fit / modal correction / both measurement factories; the two S3 batteries re-run identically through it as the equivalence gate) + tg_psi_dm96 and zwfs_dm96 stage reports S2–S6 (registration and kernel calibration, modal battery, differential head-to-head with break scale, photon-noise pricing, multi-color combination — dmg_color_comb).  Campaign READMEs carry the findings ledgers, including the corrected attributions (pattern-radius frame bias; the refuted sampling-starvation hypothesis).</a:t>
             </a:r>
           </a:p>
           <a:p>

</xml_diff>

<commit_message>
ZWFS S9 record + deck fold 3c (stencil-site fix; calibration-on-surface and fold-crossing results); slice (resources edd960b)
</commit_message>
<xml_diff>
--- a/demo_session/deck_tg_fang.pptx
+++ b/demo_session/deck_tg_fang.pptx
@@ -6026,7 +6026,7 @@
                 </a:solidFill>
                 <a:latin typeface="Arial"/>
               </a:rPr>
-              <a:t>A 10 nm change on a 30 nm working surface reads to 46 pm through the interferometer and 40 pm from one sensor frame; only the interferometer never folds</a:t>
+              <a:t>A 10 nm change on a 30 nm working surface reads to 46 pm through the interferometer and 34 pm from one sensor frame; only the interferometer never folds</a:t>
             </a:r>
           </a:p>
         </p:txBody>
@@ -6308,7 +6308,7 @@
                           </a:solidFill>
                           <a:latin typeface="Arial"/>
                         </a:rPr>
-                        <a:t>0.40</a:t>
+                        <a:t>0.35</a:t>
                       </a:r>
                     </a:p>
                   </a:txBody>
@@ -6330,7 +6330,7 @@
                           </a:solidFill>
                           <a:latin typeface="Arial"/>
                         </a:rPr>
-                        <a:t>57 pm</a:t>
+                        <a:t>63 pm</a:t>
                       </a:r>
                     </a:p>
                   </a:txBody>
@@ -6376,7 +6376,7 @@
                           </a:solidFill>
                           <a:latin typeface="Arial"/>
                         </a:rPr>
-                        <a:t>0.95</a:t>
+                        <a:t>0.93</a:t>
                       </a:r>
                     </a:p>
                   </a:txBody>
@@ -6398,7 +6398,7 @@
                           </a:solidFill>
                           <a:latin typeface="Arial"/>
                         </a:rPr>
-                        <a:t>40 pm</a:t>
+                        <a:t>34 pm</a:t>
                       </a:r>
                     </a:p>
                   </a:txBody>
@@ -6444,7 +6444,7 @@
                           </a:solidFill>
                           <a:latin typeface="Arial"/>
                         </a:rPr>
-                        <a:t>0.89</a:t>
+                        <a:t>0.87</a:t>
                       </a:r>
                     </a:p>
                   </a:txBody>
@@ -6466,7 +6466,7 @@
                           </a:solidFill>
                           <a:latin typeface="Arial"/>
                         </a:rPr>
-                        <a:t>42 pm</a:t>
+                        <a:t>36 pm</a:t>
                       </a:r>
                     </a:p>
                   </a:txBody>
@@ -6570,7 +6570,7 @@
                 </a:solidFill>
                 <a:latin typeface="Arial"/>
               </a:rPr>
-              <a:t>96×96 rig, both instruments in actuator space through one scoring library (dm_gauge_lib); sensor numbers on the corrected sensor model at its compliant sampling (385 rays across, 2048 grid; its deck), corrected for the measured modal transfer.  Records: tg96_s4_report.txt, zwfs_dm96/runs/m2048.</a:t>
+              <a:t>96×96 rig, both instruments in actuator space through one scoring library (dm_gauge_lib); sensor numbers on the corrected sensor model at its compliant sampling (385 rays across, 2048 grid; its deck), corrected for the measured modal transfer.  Records: tg96_s4_report.txt, zwfs_dm96/runs/m2048_lat.  The sensor's actuator fit samples its response pattern at the actuator centre (a 0.14 mm sampling bias found 2026-09-10); the interferometer's S3/S4 fit shares the bias and is to be re-run the same way in its reflective build.</a:t>
             </a:r>
           </a:p>
         </p:txBody>

</xml_diff>

<commit_message>
ZWFS S10 record + deck fold 3d (the measured-response-matrix calibration; matrix on the working surface -> 5 pm); slice (resources 8181893)
</commit_message>
<xml_diff>
--- a/demo_session/deck_tg_fang.pptx
+++ b/demo_session/deck_tg_fang.pptx
@@ -6026,7 +6026,7 @@
                 </a:solidFill>
                 <a:latin typeface="Arial"/>
               </a:rPr>
-              <a:t>A 10 nm change on a 30 nm working surface reads to 46 pm through the interferometer and 34 pm from one sensor frame; only the interferometer never folds</a:t>
+              <a:t>A 10 nm change on a 30 nm working surface reads to 46 pm through the interferometer and 5 pm through the sensor calibrated on that surface; only the interferometer never folds</a:t>
             </a:r>
           </a:p>
         </p:txBody>
@@ -6286,7 +6286,7 @@
                           </a:solidFill>
                           <a:latin typeface="Arial"/>
                         </a:rPr>
-                        <a:t>Zernike sensor, linear reading (one frame)</a:t>
+                        <a:t>Zernike sensor, exact reading with iterated reference and base prior (one frame; calibrated on the flat)</a:t>
                       </a:r>
                     </a:p>
                   </a:txBody>
@@ -6308,7 +6308,7 @@
                           </a:solidFill>
                           <a:latin typeface="Arial"/>
                         </a:rPr>
-                        <a:t>0.35</a:t>
+                        <a:t>0.93</a:t>
                       </a:r>
                     </a:p>
                   </a:txBody>
@@ -6330,7 +6330,7 @@
                           </a:solidFill>
                           <a:latin typeface="Arial"/>
                         </a:rPr>
-                        <a:t>63 pm</a:t>
+                        <a:t>34 pm</a:t>
                       </a:r>
                     </a:p>
                   </a:txBody>
@@ -6354,7 +6354,7 @@
                           </a:solidFill>
                           <a:latin typeface="Arial"/>
                         </a:rPr>
-                        <a:t>Zernike sensor, exact reading with iterated reference and base prior (one frame)</a:t>
+                        <a:t>Zernike sensor, phase-stepped retrieval (four frames; response matrix measured on the working surface)</a:t>
                       </a:r>
                     </a:p>
                   </a:txBody>
@@ -6376,7 +6376,7 @@
                           </a:solidFill>
                           <a:latin typeface="Arial"/>
                         </a:rPr>
-                        <a:t>0.93</a:t>
+                        <a:t>0.99</a:t>
                       </a:r>
                     </a:p>
                   </a:txBody>
@@ -6398,7 +6398,7 @@
                           </a:solidFill>
                           <a:latin typeface="Arial"/>
                         </a:rPr>
-                        <a:t>34 pm</a:t>
+                        <a:t>5 pm</a:t>
                       </a:r>
                     </a:p>
                   </a:txBody>
@@ -6422,7 +6422,7 @@
                           </a:solidFill>
                           <a:latin typeface="Arial"/>
                         </a:rPr>
-                        <a:t>Zernike sensor, phase-stepped retrieval (four frames)</a:t>
+                        <a:t>Zernike sensor, linear reading (one frame; response matrix measured on the working surface)</a:t>
                       </a:r>
                     </a:p>
                   </a:txBody>
@@ -6444,7 +6444,7 @@
                           </a:solidFill>
                           <a:latin typeface="Arial"/>
                         </a:rPr>
-                        <a:t>0.87</a:t>
+                        <a:t>1.05</a:t>
                       </a:r>
                     </a:p>
                   </a:txBody>
@@ -6466,7 +6466,7 @@
                           </a:solidFill>
                           <a:latin typeface="Arial"/>
                         </a:rPr>
-                        <a:t>36 pm</a:t>
+                        <a:t>23 pm</a:t>
                       </a:r>
                     </a:p>
                   </a:txBody>
@@ -6531,7 +6531,7 @@
                 </a:solidFill>
                 <a:latin typeface="Arial"/>
               </a:rPr>
-              <a:t>•  Verdict as measured, not assumed: the working-state axis belongs to the interferometer; the Zernike sensor reads small changes on a small working surface from one frame at a floor on par with the interferometer's.</a:t>
+              <a:t>•  Verdict as measured, not assumed: the working-state axis belongs to the interferometer; the Zernike sensor, with its response matrix measured on the working surface (64 sparse-grid states, 256 frames once), reads small changes there at a floor ten times below the interferometer's — the calibration a real DM needs anyway, and the same measurement the interferometer's own calibration should adopt.</a:t>
             </a:r>
           </a:p>
         </p:txBody>
@@ -6544,7 +6544,7 @@
         </p:nvSpPr>
         <p:spPr>
           <a:xfrm>
-            <a:off x="411480" y="5815203"/>
+            <a:off x="411480" y="6310502"/>
             <a:ext cx="11368735" cy="274320"/>
           </a:xfrm>
           <a:prstGeom prst="rect">
@@ -6570,7 +6570,7 @@
                 </a:solidFill>
                 <a:latin typeface="Arial"/>
               </a:rPr>
-              <a:t>96×96 rig, both instruments in actuator space through one scoring library (dm_gauge_lib); sensor numbers on the corrected sensor model at its compliant sampling (385 rays across, 2048 grid; its deck), corrected for the measured modal transfer.  Records: tg96_s4_report.txt, zwfs_dm96/runs/m2048_lat.  The sensor's actuator fit samples its response pattern at the actuator centre (a 0.14 mm sampling bias found 2026-09-10); the interferometer's S3/S4 fit shares the bias and is to be re-run the same way in its reflective build.</a:t>
+              <a:t>96×96 rig, both instruments in actuator space through one scoring library (dm_gauge_lib); sensor numbers on the corrected sensor model at its compliant sampling (385 rays across, 2048 grid; its deck), corrected for the measured modal transfer.  Records: tg96_s4_report.txt, zwfs_dm96/runs/m2048_lat.  Sensor rows: 385 rays; the matrix calibration = every actuator's response measured once from sparse multiplexed grids (the sensor's piston null carried as a rank-one term).  The interferometer's S3/S4 fit still uses a single-site response pattern (with a 0.14 mm stencil bias found 2026-09-10); both are to be re-run with the measured matrix in its reflective build.</a:t>
             </a:r>
           </a:p>
         </p:txBody>

</xml_diff>

<commit_message>
Decks: American English throughout (Dave's rule); zwfs slide 13 defines 'photons per state' (per measurement of one DM shape, all pixels, frames shared; not per mode/actuator) and ties it to laser power (10^14 = 31 uJ = 0.13 s at 1 mW through the test arm); loop slide footnote gives the per-cycle equivalent
Co-Authored-By: Claude Fable 5.1 <noreply@anthropic.com>
</commit_message>
<xml_diff>
--- a/demo_session/deck_tg_fang.pptx
+++ b/demo_session/deck_tg_fang.pptx
@@ -7793,7 +7793,7 @@
                 </a:solidFill>
                 <a:latin typeface="Arial"/>
               </a:rPr>
-              <a:t>Colour is a lever for neither instrument</a:t>
+              <a:t>Color is a lever for neither instrument</a:t>
             </a:r>
           </a:p>
           <a:p>
@@ -7809,7 +7809,7 @@
                 </a:solidFill>
                 <a:latin typeface="Arial"/>
               </a:rPr>
-              <a:t>On the corrected sensor model five colours lift the sensor's transfer by 3% and its rows not at all; every interferometer number holds to three digits</a:t>
+              <a:t>On the corrected sensor model five colors lift the sensor's transfer by 3% and its rows not at all; every interferometer number holds to three digits</a:t>
             </a:r>
           </a:p>
         </p:txBody>
@@ -7916,7 +7916,7 @@
                 </a:solidFill>
                 <a:latin typeface="Arial"/>
               </a:rPr>
-              <a:t>Zernike sensor, linear reading, corrected model: five colours share one smooth transfer with only the dimple's own low-order dip; the five-colour combination (orange) sits at 0.99–1.</a:t>
+              <a:t>Zernike sensor, linear reading, corrected model: five colors share one smooth transfer with only the dimple's own low-order dip; the five-color combination (orange) sits at 0.99–1.</a:t>
             </a:r>
           </a:p>
         </p:txBody>
@@ -8018,7 +8018,7 @@
                 </a:solidFill>
                 <a:latin typeface="Arial"/>
               </a:rPr>
-              <a:t>•  Sensor: the blind band that first seemed to migrate with wavelength was the defocused sensor model's Talbot null.  On the corrected model the five single-colour transfers bottom at 0.92–0.97 after the Wiener step and their combination at 0.991; on the 30 nm working surface the one-frame exact reading's SNR is 269 at 632.8 nm, 183 combined, 255 for the best pair (700 + 780 nm).  What stays chromatic is range: the reddest colour is the best single colour (smaller phase per nanometre, a 1.6 λ/D dimple).</a:t>
+              <a:t>•  Sensor: the blind band that first seemed to migrate with wavelength was the defocused sensor model's Talbot null.  On the corrected model the five single-color transfers bottom at 0.92–0.97 after the Wiener step and their combination at 0.991; on the 30 nm working surface the one-frame exact reading's SNR is 269 at 632.8 nm, 183 combined, 255 for the best pair (700 + 780 nm).  What stays chromatic is range: the reddest color is the best single color (smaller phase per nanometer, a 1.6 λ/D dimple).</a:t>
             </a:r>
           </a:p>
           <a:p>

</xml_diff>

<commit_message>
Decks + briefs: 'photons per measurement' replaces 'per state' (Dave: state-vector collision); slide 4 defines measurement and frame; per-frame counts shown for the four-frame readings; figures regenerated with the new axis labels
Co-Authored-By: Claude Fable 5.1 <noreply@anthropic.com>
</commit_message>
<xml_diff>
--- a/demo_session/deck_tg_fang.pptx
+++ b/demo_session/deck_tg_fang.pptx
@@ -6902,7 +6902,7 @@
                 </a:solidFill>
                 <a:latin typeface="Arial"/>
               </a:rPr>
-              <a:t>The interferometer reaches 1 pm at 10¹⁵ photons per DM state, the Zernike sensor's readings at 10¹⁴ — both trivial, so systematics decide</a:t>
+              <a:t>The interferometer reaches 1 pm at 10¹⁵ photons per measurement, the Zernike sensor's readings at 10¹⁴ — both trivial, so systematics decide</a:t>
             </a:r>
           </a:p>
         </p:txBody>
@@ -6985,7 +6985,7 @@
                 </a:solidFill>
                 <a:latin typeface="Arial"/>
               </a:rPr>
-              <a:t>•  Method: the optical fields do not depend on noise, so noiseless frames are captured once per DM state and photon shot noise is Monte-Carloed numerically; the photon budget per state is split across each reading's frames (interferometer 4, linear 1, stepped 4) — equal light and equal time across modalities.</a:t>
+              <a:t>•  Method: the optical fields do not depend on noise, so noiseless frames are captured once per measurement (one DM shape measured once) and photon shot noise is Monte-Carloed numerically; the photon budget per measurement is split across each reading's frames (interferometer 4, linear 1, stepped 4) — equal light and equal time across modalities.</a:t>
             </a:r>
           </a:p>
         </p:txBody>
@@ -7009,9 +7009,9 @@
                 <a:tableStyleId>{5C22544A-7EE6-4342-B048-85BDC9FD1C3A}</a:tableStyleId>
               </a:tblPr>
               <a:tblGrid>
-                <a:gridCol w="7661859"/>
+                <a:gridCol w="6935419"/>
                 <a:gridCol w="1962404"/>
-                <a:gridCol w="1744472"/>
+                <a:gridCol w="2470912"/>
               </a:tblGrid>
               <a:tr h="280035">
                 <a:tc>
@@ -7070,7 +7070,7 @@
                           </a:solidFill>
                           <a:latin typeface="Arial"/>
                         </a:rPr>
-                        <a:t>photons/state for 1 pm</a:t>
+                        <a:t>photons per measurement for 1 pm</a:t>
                       </a:r>
                     </a:p>
                   </a:txBody>

</xml_diff>